<commit_message>
AutomaTivio: setores com poucas linhas (Banks) ocupam a coluna, como no publicado
Co-Authored-By: Claude Opus 5.5 <noreply@anthropic.com>
</commit_message>
<xml_diff>
--- a/AutomaTivio/saida/2026-08/pptx/Tivio Banks - Relatório de Gestão - Agosto 2026.pptx
+++ b/AutomaTivio/saida/2026-08/pptx/Tivio Banks - Relatório de Gestão - Agosto 2026.pptx
@@ -5435,8 +5435,8 @@
         </p:nvSpPr>
         <p:spPr>
           <a:xfrm>
-            <a:off x="3802680" y="5646256"/>
-            <a:ext cx="1603929" cy="120960"/>
+            <a:off x="3802680" y="6542825"/>
+            <a:ext cx="1603929" cy="143640"/>
           </a:xfrm>
           <a:prstGeom prst="rect">
             <a:avLst/>
@@ -5449,11 +5449,11 @@
           <a:p>
             <a:pPr algn="r">
               <a:lnSpc>
-                <a:spcPts val="890"/>
-              </a:lnSpc>
-            </a:pPr>
-            <a:r>
-              <a:rPr sz="809" b="0" i="0">
+                <a:spcPts val="1047"/>
+              </a:lnSpc>
+            </a:pPr>
+            <a:r>
+              <a:rPr sz="952" b="0" i="0">
                 <a:solidFill>
                   <a:srgbClr val="222222"/>
                 </a:solidFill>
@@ -5472,8 +5472,8 @@
         </p:nvSpPr>
         <p:spPr>
           <a:xfrm>
-            <a:off x="6752497" y="5638578"/>
-            <a:ext cx="466215" cy="143640"/>
+            <a:off x="6752497" y="6533730"/>
+            <a:ext cx="524569" cy="166320"/>
           </a:xfrm>
           <a:prstGeom prst="rect">
             <a:avLst/>
@@ -5486,49 +5486,49 @@
           <a:p>
             <a:pPr algn="l">
               <a:lnSpc>
-                <a:spcPts val="1142"/>
+                <a:spcPts val="1285"/>
+              </a:lnSpc>
+            </a:pPr>
+            <a:r>
+              <a:rPr sz="1071" b="0" i="0">
+                <a:solidFill>
+                  <a:srgbClr val="5A82A0"/>
+                </a:solidFill>
+                <a:latin typeface="Versos"/>
+              </a:rPr>
+              <a:t>75,69%</a:t>
+            </a:r>
+          </a:p>
+        </p:txBody>
+      </p:sp>
+      <p:sp>
+        <p:nvSpPr>
+          <p:cNvPr id="67" name="TextBox 66"/>
+          <p:cNvSpPr txBox="1"/>
+          <p:nvPr/>
+        </p:nvSpPr>
+        <p:spPr>
+          <a:xfrm>
+            <a:off x="3802680" y="8824646"/>
+            <a:ext cx="1603929" cy="143640"/>
+          </a:xfrm>
+          <a:prstGeom prst="rect">
+            <a:avLst/>
+          </a:prstGeom>
+          <a:noFill/>
+        </p:spPr>
+        <p:txBody>
+          <a:bodyPr wrap="none" lIns="0" rIns="0" tIns="0" bIns="0" anchor="t"/>
+          <a:lstStyle/>
+          <a:p>
+            <a:pPr algn="r">
+              <a:lnSpc>
+                <a:spcPts val="1047"/>
               </a:lnSpc>
             </a:pPr>
             <a:r>
               <a:rPr sz="952" b="0" i="0">
                 <a:solidFill>
-                  <a:srgbClr val="111111"/>
-                </a:solidFill>
-                <a:latin typeface="Versos"/>
-              </a:rPr>
-              <a:t>75,69%</a:t>
-            </a:r>
-          </a:p>
-        </p:txBody>
-      </p:sp>
-      <p:sp>
-        <p:nvSpPr>
-          <p:cNvPr id="67" name="TextBox 66"/>
-          <p:cNvSpPr txBox="1"/>
-          <p:nvPr/>
-        </p:nvSpPr>
-        <p:spPr>
-          <a:xfrm>
-            <a:off x="3802680" y="6114976"/>
-            <a:ext cx="1603929" cy="120960"/>
-          </a:xfrm>
-          <a:prstGeom prst="rect">
-            <a:avLst/>
-          </a:prstGeom>
-          <a:noFill/>
-        </p:spPr>
-        <p:txBody>
-          <a:bodyPr wrap="none" lIns="0" rIns="0" tIns="0" bIns="0" anchor="t"/>
-          <a:lstStyle/>
-          <a:p>
-            <a:pPr algn="r">
-              <a:lnSpc>
-                <a:spcPts val="890"/>
-              </a:lnSpc>
-            </a:pPr>
-            <a:r>
-              <a:rPr sz="809" b="0" i="0">
-                <a:solidFill>
                   <a:srgbClr val="222222"/>
                 </a:solidFill>
                 <a:latin typeface="Versos"/>
@@ -5546,8 +5546,8 @@
         </p:nvSpPr>
         <p:spPr>
           <a:xfrm>
-            <a:off x="5892075" y="6107298"/>
-            <a:ext cx="422849" cy="143640"/>
+            <a:off x="5892075" y="8815550"/>
+            <a:ext cx="475675" cy="166320"/>
           </a:xfrm>
           <a:prstGeom prst="rect">
             <a:avLst/>
@@ -5560,13 +5560,13 @@
           <a:p>
             <a:pPr algn="l">
               <a:lnSpc>
-                <a:spcPts val="1142"/>
-              </a:lnSpc>
-            </a:pPr>
-            <a:r>
-              <a:rPr sz="952" b="0" i="0">
-                <a:solidFill>
-                  <a:srgbClr val="111111"/>
+                <a:spcPts val="1285"/>
+              </a:lnSpc>
+            </a:pPr>
+            <a:r>
+              <a:rPr sz="1071" b="0" i="0">
+                <a:solidFill>
+                  <a:srgbClr val="5A82A0"/>
                 </a:solidFill>
                 <a:latin typeface="Versos"/>
               </a:rPr>

</xml_diff>